<commit_message>
Fit CCPM references inside editable text frames after review
</commit_message>
<xml_diff>
--- a/slides/datasets-in-10-minutes-ccpm.pptx
+++ b/slides/datasets-in-10-minutes-ccpm.pptx
@@ -26133,7 +26133,7 @@
         <p:spPr>
           <a:xfrm>
             <a:off x="548640" y="1463040"/>
-            <a:ext cx="8046720" cy="1345819"/>
+            <a:ext cx="8046720" cy="1574419"/>
           </a:xfrm>
           <a:prstGeom prst="rect">
             <a:avLst/>
@@ -26281,7 +26281,7 @@
         <p:spPr>
           <a:xfrm>
             <a:off x="548640" y="3040507"/>
-            <a:ext cx="8046720" cy="1345819"/>
+            <a:ext cx="8046720" cy="1574419"/>
           </a:xfrm>
           <a:prstGeom prst="rect">
             <a:avLst/>
@@ -26543,7 +26543,7 @@
         <p:spPr>
           <a:xfrm>
             <a:off x="548640" y="1463040"/>
-            <a:ext cx="8046720" cy="1345819"/>
+            <a:ext cx="8046720" cy="1574419"/>
           </a:xfrm>
           <a:prstGeom prst="rect">
             <a:avLst/>
@@ -26691,7 +26691,7 @@
         <p:spPr>
           <a:xfrm>
             <a:off x="548640" y="3040507"/>
-            <a:ext cx="8046720" cy="1345819"/>
+            <a:ext cx="8046720" cy="1574419"/>
           </a:xfrm>
           <a:prstGeom prst="rect">
             <a:avLst/>
@@ -27101,7 +27101,7 @@
         <p:spPr>
           <a:xfrm>
             <a:off x="548640" y="3308350"/>
-            <a:ext cx="8046720" cy="1345819"/>
+            <a:ext cx="8046720" cy="1574419"/>
           </a:xfrm>
           <a:prstGeom prst="rect">
             <a:avLst/>

</xml_diff>

<commit_message>
Use natural Japanese for CCPM reuse in CLEVA
</commit_message>
<xml_diff>
--- a/slides/datasets-in-10-minutes-ccpm.pptx
+++ b/slides/datasets-in-10-minutes-ccpm.pptx
@@ -13184,7 +13184,7 @@
                 <a:ea typeface="Noto Sans CJK JP"/>
                 <a:cs typeface="Noto Sans"/>
               </a:rPr>
-              <a:t>CLEVAでの後利用と公開配布</a:t>
+              <a:t>CLEVAでの利用と公開配布</a:t>
             </a:r>
           </a:p>
         </p:txBody>
@@ -13232,7 +13232,7 @@
                 <a:ea typeface="Noto Sans CJK JP"/>
                 <a:cs typeface="Noto Sans"/>
               </a:rPr>
-              <a:t>4. CLEVAでの後利用と公開配布</a:t>
+              <a:t>4. CLEVAでの利用と公開配布</a:t>
             </a:r>
           </a:p>
         </p:txBody>
@@ -13459,7 +13459,7 @@
                 <a:ea typeface="Noto Sans CJK JP"/>
                 <a:cs typeface="Noto Sans"/>
               </a:rPr>
-              <a:t>4. CLEVAでの後利用と公開配布</a:t>
+              <a:t>4. CLEVAでの利用と公開配布</a:t>
             </a:r>
           </a:p>
         </p:txBody>
@@ -13733,7 +13733,7 @@
                 <a:ea typeface="Noto Sans CJK JP"/>
                 <a:cs typeface="Noto Sans"/>
               </a:rPr>
-              <a:t>4. CLEVAでの後利用と公開配布</a:t>
+              <a:t>4. CLEVAでの利用と公開配布</a:t>
             </a:r>
           </a:p>
         </p:txBody>
@@ -13996,7 +13996,7 @@
                 <a:ea typeface="Noto Sans CJK JP"/>
                 <a:cs typeface="Noto Sans"/>
               </a:rPr>
-              <a:t>4. CLEVAでの後利用と公開配布</a:t>
+              <a:t>4. CLEVAでの利用と公開配布</a:t>
             </a:r>
           </a:p>
         </p:txBody>
@@ -14333,7 +14333,7 @@
                 <a:ea typeface="Noto Sans CJK JP"/>
                 <a:cs typeface="Noto Sans"/>
               </a:rPr>
-              <a:t>CLEVAでの後利用と公開配布</a:t>
+              <a:t>CLEVAでの利用と公開配布</a:t>
             </a:r>
           </a:p>
         </p:txBody>

</xml_diff>